<commit_message>
feat: ecosistema elevado 10x — 10 MDs + exports + invitaciones verificadas
10 MDs elevados a calidad 10x (sin inflar):
- Ejecutivas ES+EN: criterios aceptacion, 3 escenarios ROI, riesgos, limites
- Detalladas ES+EN: 19 secciones, pricing logic, edge cases, glosario
- KYC: barreras sector, madurez digital, WhatsApp vs email, friccion pago
- Due-diligence: risk scoring, exit scenarios, IP protection, escalacion
- Procurement: switching costs, free tier limits, compliance
- Market-research: timing, TAM validation, SAM sensitivity
- Forecast: sensitivity 3 escenarios, cash flow timing, estacionalidad
- Revenue: break-even sensitivity, capacity ceiling, ambassador funnel, churn

Exports regenerados: 4 DOCX + 2 XLSX + 2 PPTX

Invitaciones verificadas:
- 0 mailto, 0 auto-entrenar, 0 equity viejo
- Masterclass, experiencia, footer homologado en todos
- Countdown correcto (lun 6 abril 7PM)

Co-Authored-By: Claude Opus 4.6 (1M context) <noreply@anthropic.com>
</commit_message>
<xml_diff>
--- a/propuesta-bootcamp-ejecutivo-quito-2026/outputs/export/pitch-deck-en.pptx
+++ b/propuesta-bootcamp-ejecutivo-quito-2026/outputs/export/pitch-deck-en.pptx
@@ -2982,7 +2982,7 @@
                 <a:ea typeface="Arial" pitchFamily="34" charset="-122"/>
                 <a:cs typeface="Arial" pitchFamily="34" charset="-120"/>
               </a:rPr>
-              <a:t>19%</a:t>
+              <a:t>51%</a:t>
             </a:r>
             <a:endParaRPr lang="en-US" sz="2800" dirty="0"/>
           </a:p>
@@ -3082,7 +3082,7 @@
                 <a:ea typeface="Arial" pitchFamily="34" charset="-122"/>
                 <a:cs typeface="Arial" pitchFamily="34" charset="-120"/>
               </a:rPr>
-              <a:t>Cristian Jarrin</a:t>
+              <a:t>Katherin Oquendo</a:t>
             </a:r>
             <a:endParaRPr lang="en-US" sz="1800" dirty="0"/>
           </a:p>
@@ -3121,7 +3121,7 @@
                 <a:ea typeface="Arial" pitchFamily="34" charset="-122"/>
                 <a:cs typeface="Arial" pitchFamily="34" charset="-120"/>
               </a:rPr>
-              <a:t>MetodologIA Ecuador Co-Founder</a:t>
+              <a:t>MetodologIA Co-Founder</a:t>
             </a:r>
             <a:endParaRPr lang="en-US" sz="1400" dirty="0"/>
           </a:p>
@@ -3160,7 +3160,7 @@
                 <a:ea typeface="Arial" pitchFamily="34" charset="-122"/>
                 <a:cs typeface="Arial" pitchFamily="34" charset="-120"/>
               </a:rPr>
-              <a:t>51%</a:t>
+              <a:t>10%</a:t>
             </a:r>
             <a:endParaRPr lang="en-US" sz="2800" dirty="0"/>
           </a:p>
@@ -3199,7 +3199,7 @@
                 <a:ea typeface="Arial" pitchFamily="34" charset="-122"/>
                 <a:cs typeface="Arial" pitchFamily="34" charset="-120"/>
               </a:rPr>
-              <a:t>Territorial operator. Business relationships in Quito, logistics, outreach.</a:t>
+              <a:t>Co-founder. Operations and strategy.</a:t>
             </a:r>
             <a:endParaRPr lang="en-US" sz="1100" dirty="0"/>
           </a:p>
@@ -3260,7 +3260,7 @@
                 <a:ea typeface="Arial" pitchFamily="34" charset="-122"/>
                 <a:cs typeface="Arial" pitchFamily="34" charset="-120"/>
               </a:rPr>
-              <a:t>MetodologIA Holding</a:t>
+              <a:t>Daniel</a:t>
             </a:r>
             <a:endParaRPr lang="en-US" sz="1800" dirty="0"/>
           </a:p>
@@ -3299,7 +3299,7 @@
                 <a:ea typeface="Arial" pitchFamily="34" charset="-122"/>
                 <a:cs typeface="Arial" pitchFamily="34" charset="-120"/>
               </a:rPr>
-              <a:t>Corporate entity</a:t>
+              <a:t>MetodologIA Co-Founder</a:t>
             </a:r>
             <a:endParaRPr lang="en-US" sz="1400" dirty="0"/>
           </a:p>
@@ -3338,7 +3338,7 @@
                 <a:ea typeface="Arial" pitchFamily="34" charset="-122"/>
                 <a:cs typeface="Arial" pitchFamily="34" charset="-120"/>
               </a:rPr>
-              <a:t>30%</a:t>
+              <a:t>13%</a:t>
             </a:r>
             <a:endParaRPr lang="en-US" sz="2800" dirty="0"/>
           </a:p>
@@ -3377,7 +3377,363 @@
                 <a:ea typeface="Arial" pitchFamily="34" charset="-122"/>
                 <a:cs typeface="Arial" pitchFamily="34" charset="-120"/>
               </a:rPr>
-              <a:t>IP, brand, tech ecosystem, ambassador network.</a:t>
+              <a:t>Co-founder. Accelerators and founders network.</a:t>
+            </a:r>
+            <a:endParaRPr lang="en-US" sz="1100" dirty="0"/>
+          </a:p>
+        </p:txBody>
+      </p:sp>
+      <p:sp>
+        <p:nvSpPr>
+          <p:cNvPr id="21" name="Shape 19"/>
+          <p:cNvSpPr/>
+          <p:nvPr/>
+        </p:nvSpPr>
+        <p:spPr>
+          <a:xfrm>
+            <a:off x="11704320" y="1463040"/>
+            <a:ext cx="3200400" cy="3657600"/>
+          </a:xfrm>
+          <a:prstGeom prst="roundRect">
+            <a:avLst>
+              <a:gd name="adj" fmla="val 2857"/>
+            </a:avLst>
+          </a:prstGeom>
+          <a:solidFill>
+            <a:srgbClr val="071A33"/>
+          </a:solidFill>
+          <a:ln/>
+        </p:spPr>
+      </p:sp>
+      <p:sp>
+        <p:nvSpPr>
+          <p:cNvPr id="22" name="Text 20"/>
+          <p:cNvSpPr/>
+          <p:nvPr/>
+        </p:nvSpPr>
+        <p:spPr>
+          <a:xfrm>
+            <a:off x="11704320" y="1828800"/>
+            <a:ext cx="3200400" cy="457200"/>
+          </a:xfrm>
+          <a:prstGeom prst="rect">
+            <a:avLst/>
+          </a:prstGeom>
+          <a:noFill/>
+          <a:ln/>
+        </p:spPr>
+        <p:txBody>
+          <a:bodyPr wrap="square" rtlCol="0" anchor="ctr"/>
+          <a:lstStyle/>
+          <a:p>
+            <a:pPr algn="ctr" indent="0" marL="0">
+              <a:buNone/>
+            </a:pPr>
+            <a:r>
+              <a:rPr lang="en-US" sz="1800" b="1" dirty="0">
+                <a:solidFill>
+                  <a:srgbClr val="FFFFFF"/>
+                </a:solidFill>
+                <a:latin typeface="Arial" pitchFamily="34" charset="0"/>
+                <a:ea typeface="Arial" pitchFamily="34" charset="-122"/>
+                <a:cs typeface="Arial" pitchFamily="34" charset="-120"/>
+              </a:rPr>
+              <a:t>German</a:t>
+            </a:r>
+            <a:endParaRPr lang="en-US" sz="1800" dirty="0"/>
+          </a:p>
+        </p:txBody>
+      </p:sp>
+      <p:sp>
+        <p:nvSpPr>
+          <p:cNvPr id="23" name="Text 21"/>
+          <p:cNvSpPr/>
+          <p:nvPr/>
+        </p:nvSpPr>
+        <p:spPr>
+          <a:xfrm>
+            <a:off x="11704320" y="2377440"/>
+            <a:ext cx="3200400" cy="365760"/>
+          </a:xfrm>
+          <a:prstGeom prst="rect">
+            <a:avLst/>
+          </a:prstGeom>
+          <a:noFill/>
+          <a:ln/>
+        </p:spPr>
+        <p:txBody>
+          <a:bodyPr wrap="square" rtlCol="0" anchor="ctr"/>
+          <a:lstStyle/>
+          <a:p>
+            <a:pPr algn="ctr" indent="0" marL="0">
+              <a:buNone/>
+            </a:pPr>
+            <a:r>
+              <a:rPr lang="en-US" sz="1400" dirty="0">
+                <a:solidFill>
+                  <a:srgbClr val="FFD700"/>
+                </a:solidFill>
+                <a:latin typeface="Arial" pitchFamily="34" charset="0"/>
+                <a:ea typeface="Arial" pitchFamily="34" charset="-122"/>
+                <a:cs typeface="Arial" pitchFamily="34" charset="-120"/>
+              </a:rPr>
+              <a:t>MetodologIA Co-Founder</a:t>
+            </a:r>
+            <a:endParaRPr lang="en-US" sz="1400" dirty="0"/>
+          </a:p>
+        </p:txBody>
+      </p:sp>
+      <p:sp>
+        <p:nvSpPr>
+          <p:cNvPr id="24" name="Text 22"/>
+          <p:cNvSpPr/>
+          <p:nvPr/>
+        </p:nvSpPr>
+        <p:spPr>
+          <a:xfrm>
+            <a:off x="11704320" y="2926080"/>
+            <a:ext cx="3200400" cy="457200"/>
+          </a:xfrm>
+          <a:prstGeom prst="rect">
+            <a:avLst/>
+          </a:prstGeom>
+          <a:noFill/>
+          <a:ln/>
+        </p:spPr>
+        <p:txBody>
+          <a:bodyPr wrap="square" rtlCol="0" anchor="ctr"/>
+          <a:lstStyle/>
+          <a:p>
+            <a:pPr algn="ctr" indent="0" marL="0">
+              <a:buNone/>
+            </a:pPr>
+            <a:r>
+              <a:rPr lang="en-US" sz="2800" b="1" dirty="0">
+                <a:solidFill>
+                  <a:srgbClr val="FFD700"/>
+                </a:solidFill>
+                <a:latin typeface="Arial" pitchFamily="34" charset="0"/>
+                <a:ea typeface="Arial" pitchFamily="34" charset="-122"/>
+                <a:cs typeface="Arial" pitchFamily="34" charset="-120"/>
+              </a:rPr>
+              <a:t>19%</a:t>
+            </a:r>
+            <a:endParaRPr lang="en-US" sz="2800" dirty="0"/>
+          </a:p>
+        </p:txBody>
+      </p:sp>
+      <p:sp>
+        <p:nvSpPr>
+          <p:cNvPr id="25" name="Text 23"/>
+          <p:cNvSpPr/>
+          <p:nvPr/>
+        </p:nvSpPr>
+        <p:spPr>
+          <a:xfrm>
+            <a:off x="11887200" y="3657600"/>
+            <a:ext cx="2834640" cy="1097280"/>
+          </a:xfrm>
+          <a:prstGeom prst="rect">
+            <a:avLst/>
+          </a:prstGeom>
+          <a:noFill/>
+          <a:ln/>
+        </p:spPr>
+        <p:txBody>
+          <a:bodyPr wrap="square" rtlCol="0" anchor="ctr"/>
+          <a:lstStyle/>
+          <a:p>
+            <a:pPr algn="ctr" indent="0" marL="0">
+              <a:buNone/>
+            </a:pPr>
+            <a:r>
+              <a:rPr lang="en-US" sz="1100" dirty="0">
+                <a:solidFill>
+                  <a:srgbClr val="94A3B8"/>
+                </a:solidFill>
+                <a:latin typeface="Arial" pitchFamily="34" charset="0"/>
+                <a:ea typeface="Arial" pitchFamily="34" charset="-122"/>
+                <a:cs typeface="Arial" pitchFamily="34" charset="-120"/>
+              </a:rPr>
+              <a:t>Co-founder. Accelerators and founders support.</a:t>
+            </a:r>
+            <a:endParaRPr lang="en-US" sz="1100" dirty="0"/>
+          </a:p>
+        </p:txBody>
+      </p:sp>
+      <p:sp>
+        <p:nvSpPr>
+          <p:cNvPr id="26" name="Shape 24"/>
+          <p:cNvSpPr/>
+          <p:nvPr/>
+        </p:nvSpPr>
+        <p:spPr>
+          <a:xfrm>
+            <a:off x="15361920" y="1463040"/>
+            <a:ext cx="3200400" cy="3657600"/>
+          </a:xfrm>
+          <a:prstGeom prst="roundRect">
+            <a:avLst>
+              <a:gd name="adj" fmla="val 2857"/>
+            </a:avLst>
+          </a:prstGeom>
+          <a:solidFill>
+            <a:srgbClr val="071A33"/>
+          </a:solidFill>
+          <a:ln/>
+        </p:spPr>
+      </p:sp>
+      <p:sp>
+        <p:nvSpPr>
+          <p:cNvPr id="27" name="Text 25"/>
+          <p:cNvSpPr/>
+          <p:nvPr/>
+        </p:nvSpPr>
+        <p:spPr>
+          <a:xfrm>
+            <a:off x="15361920" y="1828800"/>
+            <a:ext cx="3200400" cy="457200"/>
+          </a:xfrm>
+          <a:prstGeom prst="rect">
+            <a:avLst/>
+          </a:prstGeom>
+          <a:noFill/>
+          <a:ln/>
+        </p:spPr>
+        <p:txBody>
+          <a:bodyPr wrap="square" rtlCol="0" anchor="ctr"/>
+          <a:lstStyle/>
+          <a:p>
+            <a:pPr algn="ctr" indent="0" marL="0">
+              <a:buNone/>
+            </a:pPr>
+            <a:r>
+              <a:rPr lang="en-US" sz="1800" b="1" dirty="0">
+                <a:solidFill>
+                  <a:srgbClr val="FFFFFF"/>
+                </a:solidFill>
+                <a:latin typeface="Arial" pitchFamily="34" charset="0"/>
+                <a:ea typeface="Arial" pitchFamily="34" charset="-122"/>
+                <a:cs typeface="Arial" pitchFamily="34" charset="-120"/>
+              </a:rPr>
+              <a:t>Cristian Jarrin</a:t>
+            </a:r>
+            <a:endParaRPr lang="en-US" sz="1800" dirty="0"/>
+          </a:p>
+        </p:txBody>
+      </p:sp>
+      <p:sp>
+        <p:nvSpPr>
+          <p:cNvPr id="28" name="Text 26"/>
+          <p:cNvSpPr/>
+          <p:nvPr/>
+        </p:nvSpPr>
+        <p:spPr>
+          <a:xfrm>
+            <a:off x="15361920" y="2377440"/>
+            <a:ext cx="3200400" cy="365760"/>
+          </a:xfrm>
+          <a:prstGeom prst="rect">
+            <a:avLst/>
+          </a:prstGeom>
+          <a:noFill/>
+          <a:ln/>
+        </p:spPr>
+        <p:txBody>
+          <a:bodyPr wrap="square" rtlCol="0" anchor="ctr"/>
+          <a:lstStyle/>
+          <a:p>
+            <a:pPr algn="ctr" indent="0" marL="0">
+              <a:buNone/>
+            </a:pPr>
+            <a:r>
+              <a:rPr lang="en-US" sz="1400" dirty="0">
+                <a:solidFill>
+                  <a:srgbClr val="FFD700"/>
+                </a:solidFill>
+                <a:latin typeface="Arial" pitchFamily="34" charset="0"/>
+                <a:ea typeface="Arial" pitchFamily="34" charset="-122"/>
+                <a:cs typeface="Arial" pitchFamily="34" charset="-120"/>
+              </a:rPr>
+              <a:t>MetodologIA Ecuador Partner (joins 1 year later)</a:t>
+            </a:r>
+            <a:endParaRPr lang="en-US" sz="1400" dirty="0"/>
+          </a:p>
+        </p:txBody>
+      </p:sp>
+      <p:sp>
+        <p:nvSpPr>
+          <p:cNvPr id="29" name="Text 27"/>
+          <p:cNvSpPr/>
+          <p:nvPr/>
+        </p:nvSpPr>
+        <p:spPr>
+          <a:xfrm>
+            <a:off x="15361920" y="2926080"/>
+            <a:ext cx="3200400" cy="457200"/>
+          </a:xfrm>
+          <a:prstGeom prst="rect">
+            <a:avLst/>
+          </a:prstGeom>
+          <a:noFill/>
+          <a:ln/>
+        </p:spPr>
+        <p:txBody>
+          <a:bodyPr wrap="square" rtlCol="0" anchor="ctr"/>
+          <a:lstStyle/>
+          <a:p>
+            <a:pPr algn="ctr" indent="0" marL="0">
+              <a:buNone/>
+            </a:pPr>
+            <a:r>
+              <a:rPr lang="en-US" sz="2800" b="1" dirty="0">
+                <a:solidFill>
+                  <a:srgbClr val="FFD700"/>
+                </a:solidFill>
+                <a:latin typeface="Arial" pitchFamily="34" charset="0"/>
+                <a:ea typeface="Arial" pitchFamily="34" charset="-122"/>
+                <a:cs typeface="Arial" pitchFamily="34" charset="-120"/>
+              </a:rPr>
+              <a:t>7%</a:t>
+            </a:r>
+            <a:endParaRPr lang="en-US" sz="2800" dirty="0"/>
+          </a:p>
+        </p:txBody>
+      </p:sp>
+      <p:sp>
+        <p:nvSpPr>
+          <p:cNvPr id="30" name="Text 28"/>
+          <p:cNvSpPr/>
+          <p:nvPr/>
+        </p:nvSpPr>
+        <p:spPr>
+          <a:xfrm>
+            <a:off x="15544800" y="3657600"/>
+            <a:ext cx="2834640" cy="1097280"/>
+          </a:xfrm>
+          <a:prstGeom prst="rect">
+            <a:avLst/>
+          </a:prstGeom>
+          <a:noFill/>
+          <a:ln/>
+        </p:spPr>
+        <p:txBody>
+          <a:bodyPr wrap="square" rtlCol="0" anchor="ctr"/>
+          <a:lstStyle/>
+          <a:p>
+            <a:pPr algn="ctr" indent="0" marL="0">
+              <a:buNone/>
+            </a:pPr>
+            <a:r>
+              <a:rPr lang="en-US" sz="1100" dirty="0">
+                <a:solidFill>
+                  <a:srgbClr val="94A3B8"/>
+                </a:solidFill>
+                <a:latin typeface="Arial" pitchFamily="34" charset="0"/>
+                <a:ea typeface="Arial" pitchFamily="34" charset="-122"/>
+                <a:cs typeface="Arial" pitchFamily="34" charset="-120"/>
+              </a:rPr>
+              <a:t>Territorial operator. Business relationships in Quito, logistics, outreach.</a:t>
             </a:r>
             <a:endParaRPr lang="en-US" sz="1100" dirty="0"/>
           </a:p>

</xml_diff>